<commit_message>
feat: consolidate project inputs into canonical bundles
</commit_message>
<xml_diff>
--- a/website/public/generated/LMD-Bridgs/05_samco_pco_31_slide_report.pptx
+++ b/website/public/generated/LMD-Bridgs/05_samco_pco_31_slide_report.pptx
@@ -3191,7 +3191,7 @@
               </a:defRPr>
             </a:pPr>
             <a:r>
-              <a:t>LMD Bridge &amp; Road Interchange | 30 data-driven control sections | 2026-08-14T03:05:27+00:00</a:t>
+              <a:t>LMD Bridge &amp; Road Interchange | 30 data-driven control sections | 2026-08-15T05:30:57+00:00</a:t>
             </a:r>
           </a:p>
         </p:txBody>
@@ -3369,7 +3369,7 @@
               </a:defRPr>
             </a:pPr>
             <a:r>
-              <a:t>evm: 01-data/import_templates/evm.csv (17 rows)</a:t>
+              <a:t>evm: 01-data/import_templates/project_input_bundle.csv (17 rows)</a:t>
             </a:r>
           </a:p>
         </p:txBody>
@@ -4821,7 +4821,7 @@
               </a:defRPr>
             </a:pPr>
             <a:r>
-              <a:t>evm: 01-data/import_templates/evm.csv (17 rows)</a:t>
+              <a:t>evm: 01-data/import_templates/project_input_bundle.csv (17 rows)</a:t>
             </a:r>
           </a:p>
         </p:txBody>
@@ -8453,7 +8453,7 @@
               </a:defRPr>
             </a:pPr>
             <a:r>
-              <a:t>activities: 01-data/import_templates/activities.csv (17 rows)</a:t>
+              <a:t>activities: 01-data/import_templates/project_input_bundle.csv (17 rows)</a:t>
             </a:r>
           </a:p>
         </p:txBody>
@@ -9896,7 +9896,7 @@
               </a:defRPr>
             </a:pPr>
             <a:r>
-              <a:t>activities: 01-data/import_templates/activities.csv (17 rows)</a:t>
+              <a:t>activities: 01-data/import_templates/project_input_bundle.csv (17 rows)</a:t>
             </a:r>
           </a:p>
         </p:txBody>
@@ -11339,7 +11339,7 @@
               </a:defRPr>
             </a:pPr>
             <a:r>
-              <a:t>activities: 01-data/import_templates/activities.csv (17 rows)</a:t>
+              <a:t>activities: 01-data/import_templates/project_input_bundle.csv (17 rows)</a:t>
             </a:r>
           </a:p>
         </p:txBody>
@@ -12794,7 +12794,7 @@
               </a:defRPr>
             </a:pPr>
             <a:r>
-              <a:t>activities: 01-data/import_templates/activities.csv (17 rows)</a:t>
+              <a:t>activities: 01-data/import_templates/project_input_bundle.csv (17 rows)</a:t>
             </a:r>
           </a:p>
         </p:txBody>
@@ -14249,7 +14249,7 @@
               </a:defRPr>
             </a:pPr>
             <a:r>
-              <a:t>activities: 01-data/import_templates/activities.csv (17 rows)</a:t>
+              <a:t>activities: 01-data/import_templates/project_input_bundle.csv (17 rows)</a:t>
             </a:r>
           </a:p>
         </p:txBody>
@@ -17781,7 +17781,7 @@
               </a:defRPr>
             </a:pPr>
             <a:r>
-              <a:t>activities: 01-data/import_templates/activities.csv (17 rows)</a:t>
+              <a:t>activities: 01-data/import_templates/project_input_bundle.csv (17 rows)</a:t>
             </a:r>
           </a:p>
           <a:p>
@@ -17793,7 +17793,7 @@
               </a:defRPr>
             </a:pPr>
             <a:r>
-              <a:t>progress: 01-data/import_templates/progress_updates.csv (17 rows)</a:t>
+              <a:t>progress: 01-data/import_templates/project_input_bundle.csv (17 rows)</a:t>
             </a:r>
           </a:p>
         </p:txBody>
@@ -19248,7 +19248,7 @@
               </a:defRPr>
             </a:pPr>
             <a:r>
-              <a:t>activities: 01-data/import_templates/activities.csv (17 rows)</a:t>
+              <a:t>activities: 01-data/import_templates/project_input_bundle.csv (17 rows)</a:t>
             </a:r>
           </a:p>
           <a:p>
@@ -19260,7 +19260,7 @@
               </a:defRPr>
             </a:pPr>
             <a:r>
-              <a:t>evm: 01-data/import_templates/evm.csv (17 rows)</a:t>
+              <a:t>evm: 01-data/import_templates/project_input_bundle.csv (17 rows)</a:t>
             </a:r>
           </a:p>
           <a:p>
@@ -19724,7 +19724,7 @@
               </a:defRPr>
             </a:pPr>
             <a:r>
-              <a:t>activities: 01-data/import_templates/activities.csv (17 rows)</a:t>
+              <a:t>activities: 01-data/import_templates/project_input_bundle.csv (17 rows)</a:t>
             </a:r>
           </a:p>
         </p:txBody>
@@ -21167,7 +21167,7 @@
               </a:defRPr>
             </a:pPr>
             <a:r>
-              <a:t>activities: 01-data/import_templates/activities.csv (17 rows)</a:t>
+              <a:t>activities: 01-data/import_templates/project_input_bundle.csv (17 rows)</a:t>
             </a:r>
           </a:p>
           <a:p>
@@ -21179,7 +21179,7 @@
               </a:defRPr>
             </a:pPr>
             <a:r>
-              <a:t>evm: 01-data/import_templates/evm.csv (17 rows)</a:t>
+              <a:t>evm: 01-data/import_templates/project_input_bundle.csv (17 rows)</a:t>
             </a:r>
           </a:p>
         </p:txBody>
@@ -22622,7 +22622,7 @@
               </a:defRPr>
             </a:pPr>
             <a:r>
-              <a:t>activities: 01-data/import_templates/activities.csv (17 rows)</a:t>
+              <a:t>activities: 01-data/import_templates/project_input_bundle.csv (17 rows)</a:t>
             </a:r>
           </a:p>
           <a:p>
@@ -22634,7 +22634,7 @@
               </a:defRPr>
             </a:pPr>
             <a:r>
-              <a:t>evm: 01-data/import_templates/evm.csv (17 rows)</a:t>
+              <a:t>evm: 01-data/import_templates/project_input_bundle.csv (17 rows)</a:t>
             </a:r>
           </a:p>
           <a:p>
@@ -26411,7 +26411,7 @@
               </a:defRPr>
             </a:pPr>
             <a:r>
-              <a:t>activities: 01-data/import_templates/activities.csv (17 rows)</a:t>
+              <a:t>activities: 01-data/import_templates/project_input_bundle.csv (17 rows)</a:t>
             </a:r>
           </a:p>
           <a:p>
@@ -26423,7 +26423,7 @@
               </a:defRPr>
             </a:pPr>
             <a:r>
-              <a:t>progress: 01-data/import_templates/progress_updates.csv (17 rows)</a:t>
+              <a:t>progress: 01-data/import_templates/project_input_bundle.csv (17 rows)</a:t>
             </a:r>
           </a:p>
         </p:txBody>
@@ -27878,7 +27878,7 @@
               </a:defRPr>
             </a:pPr>
             <a:r>
-              <a:t>activities: 01-data/import_templates/activities.csv (17 rows)</a:t>
+              <a:t>activities: 01-data/import_templates/project_input_bundle.csv (17 rows)</a:t>
             </a:r>
           </a:p>
         </p:txBody>
@@ -30753,7 +30753,7 @@
               </a:defRPr>
             </a:pPr>
             <a:r>
-              <a:t>activities: 01-data/import_templates/activities.csv (17 rows)</a:t>
+              <a:t>activities: 01-data/import_templates/project_input_bundle.csv (17 rows)</a:t>
             </a:r>
           </a:p>
         </p:txBody>

</xml_diff>